<commit_message>
updated PDF and PPT files for the 11th presentation
</commit_message>
<xml_diff>
--- a/11/11_eloadas_webbiztonsag_alapjai.pptx
+++ b/11/11_eloadas_webbiztonsag_alapjai.pptx
@@ -212,7 +212,7 @@
           <a:p>
             <a:fld id="{4C482E4E-5CEC-44A9-BF2B-512FB3B5604F}" type="datetimeFigureOut">
               <a:rPr lang="en-US" smtClean="0"/>
-              <a:t>2/2/2026</a:t>
+              <a:t>4/26/2026</a:t>
             </a:fld>
             <a:endParaRPr lang="en-US"/>
           </a:p>
@@ -2830,7 +2830,7 @@
             </a:r>
             <a:r>
               <a:rPr lang="hu-HU" dirty="0"/>
-              <a:t>, mert jobb növeli a </a:t>
+              <a:t>, mert jobban növeli a </a:t>
             </a:r>
             <a:r>
               <a:rPr lang="hu-HU" b="1" dirty="0"/>
@@ -7439,7 +7439,7 @@
           <a:p>
             <a:fld id="{E80C50CD-E178-4744-9B35-B2F624D6C5E9}" type="datetimeFigureOut">
               <a:rPr lang="en-US" smtClean="0"/>
-              <a:t>2/2/2026</a:t>
+              <a:t>4/26/2026</a:t>
             </a:fld>
             <a:endParaRPr lang="en-US"/>
           </a:p>
@@ -7637,7 +7637,7 @@
           <a:p>
             <a:fld id="{E80C50CD-E178-4744-9B35-B2F624D6C5E9}" type="datetimeFigureOut">
               <a:rPr lang="en-US" smtClean="0"/>
-              <a:t>2/2/2026</a:t>
+              <a:t>4/26/2026</a:t>
             </a:fld>
             <a:endParaRPr lang="en-US"/>
           </a:p>
@@ -7845,7 +7845,7 @@
           <a:p>
             <a:fld id="{E80C50CD-E178-4744-9B35-B2F624D6C5E9}" type="datetimeFigureOut">
               <a:rPr lang="en-US" smtClean="0"/>
-              <a:t>2/2/2026</a:t>
+              <a:t>4/26/2026</a:t>
             </a:fld>
             <a:endParaRPr lang="en-US"/>
           </a:p>
@@ -8095,7 +8095,7 @@
           <a:p>
             <a:fld id="{E80C50CD-E178-4744-9B35-B2F624D6C5E9}" type="datetimeFigureOut">
               <a:rPr lang="en-US" smtClean="0"/>
-              <a:t>2/2/2026</a:t>
+              <a:t>4/26/2026</a:t>
             </a:fld>
             <a:endParaRPr lang="en-US"/>
           </a:p>
@@ -8374,7 +8374,7 @@
           <a:p>
             <a:fld id="{E80C50CD-E178-4744-9B35-B2F624D6C5E9}" type="datetimeFigureOut">
               <a:rPr lang="en-US" smtClean="0"/>
-              <a:t>2/2/2026</a:t>
+              <a:t>4/26/2026</a:t>
             </a:fld>
             <a:endParaRPr lang="en-US"/>
           </a:p>
@@ -8691,7 +8691,7 @@
           <a:p>
             <a:fld id="{E80C50CD-E178-4744-9B35-B2F624D6C5E9}" type="datetimeFigureOut">
               <a:rPr lang="en-US" smtClean="0"/>
-              <a:t>2/2/2026</a:t>
+              <a:t>4/26/2026</a:t>
             </a:fld>
             <a:endParaRPr lang="en-US"/>
           </a:p>
@@ -9107,7 +9107,7 @@
           <a:p>
             <a:fld id="{E80C50CD-E178-4744-9B35-B2F624D6C5E9}" type="datetimeFigureOut">
               <a:rPr lang="en-US" smtClean="0"/>
-              <a:t>2/2/2026</a:t>
+              <a:t>4/26/2026</a:t>
             </a:fld>
             <a:endParaRPr lang="en-US"/>
           </a:p>
@@ -9248,7 +9248,7 @@
           <a:p>
             <a:fld id="{E80C50CD-E178-4744-9B35-B2F624D6C5E9}" type="datetimeFigureOut">
               <a:rPr lang="en-US" smtClean="0"/>
-              <a:t>2/2/2026</a:t>
+              <a:t>4/26/2026</a:t>
             </a:fld>
             <a:endParaRPr lang="en-US"/>
           </a:p>
@@ -9361,7 +9361,7 @@
           <a:p>
             <a:fld id="{E80C50CD-E178-4744-9B35-B2F624D6C5E9}" type="datetimeFigureOut">
               <a:rPr lang="en-US" smtClean="0"/>
-              <a:t>2/2/2026</a:t>
+              <a:t>4/26/2026</a:t>
             </a:fld>
             <a:endParaRPr lang="en-US"/>
           </a:p>
@@ -9678,7 +9678,7 @@
           <a:p>
             <a:fld id="{E80C50CD-E178-4744-9B35-B2F624D6C5E9}" type="datetimeFigureOut">
               <a:rPr lang="en-US" smtClean="0"/>
-              <a:t>2/2/2026</a:t>
+              <a:t>4/26/2026</a:t>
             </a:fld>
             <a:endParaRPr lang="en-US"/>
           </a:p>
@@ -9970,7 +9970,7 @@
           <a:p>
             <a:fld id="{E80C50CD-E178-4744-9B35-B2F624D6C5E9}" type="datetimeFigureOut">
               <a:rPr lang="en-US" smtClean="0"/>
-              <a:t>2/2/2026</a:t>
+              <a:t>4/26/2026</a:t>
             </a:fld>
             <a:endParaRPr lang="en-US"/>
           </a:p>
@@ -10210,7 +10210,7 @@
             <a:fld id="{E80C50CD-E178-4744-9B35-B2F624D6C5E9}" type="datetimeFigureOut">
               <a:rPr lang="en-US" smtClean="0"/>
               <a:pPr/>
-              <a:t>2/2/2026</a:t>
+              <a:t>4/26/2026</a:t>
             </a:fld>
             <a:endParaRPr lang="en-US"/>
           </a:p>
@@ -12714,8 +12714,8 @@
         </p:nvSpPr>
         <p:spPr bwMode="auto">
           <a:xfrm>
-            <a:off x="521208" y="2177486"/>
-            <a:ext cx="10833557" cy="2793842"/>
+            <a:off x="521208" y="1746600"/>
+            <a:ext cx="10833557" cy="3655616"/>
           </a:xfrm>
           <a:prstGeom prst="rect">
             <a:avLst/>
@@ -12762,6 +12762,38 @@
             <a:spAutoFit/>
           </a:bodyPr>
           <a:lstStyle/>
+          <a:p>
+            <a:pPr marL="0" lvl="0" indent="0" eaLnBrk="0" fontAlgn="base" hangingPunct="0">
+              <a:lnSpc>
+                <a:spcPct val="200000"/>
+              </a:lnSpc>
+              <a:spcBef>
+                <a:spcPct val="0"/>
+              </a:spcBef>
+              <a:spcAft>
+                <a:spcPct val="0"/>
+              </a:spcAft>
+              <a:buNone/>
+            </a:pPr>
+            <a:r>
+              <a:rPr lang="hu-HU" sz="2800" b="1" dirty="0">
+                <a:latin typeface="Arial" panose="020B0604020202020204" pitchFamily="34" charset="0"/>
+                <a:cs typeface="Arial" panose="020B0604020202020204" pitchFamily="34" charset="0"/>
+              </a:rPr>
+              <a:t>Eltérő eredetű erőforrások megosztása</a:t>
+            </a:r>
+            <a:endParaRPr kumimoji="0" lang="hu-HU" altLang="en-US" sz="2400" b="1" i="0" u="none" strike="noStrike" cap="none" normalizeH="0" baseline="0" dirty="0">
+              <a:ln>
+                <a:noFill/>
+              </a:ln>
+              <a:solidFill>
+                <a:schemeClr val="tx1"/>
+              </a:solidFill>
+              <a:effectLst/>
+              <a:latin typeface="Arial" panose="020B0604020202020204" pitchFamily="34" charset="0"/>
+              <a:cs typeface="Arial" panose="020B0604020202020204" pitchFamily="34" charset="0"/>
+            </a:endParaRPr>
+          </a:p>
           <a:p>
             <a:pPr marL="0" lvl="0" indent="0" eaLnBrk="0" fontAlgn="base" hangingPunct="0">
               <a:lnSpc>
@@ -14205,8 +14237,8 @@
         </p:nvSpPr>
         <p:spPr bwMode="auto">
           <a:xfrm>
-            <a:off x="521208" y="2245996"/>
-            <a:ext cx="7928311" cy="3163174"/>
+            <a:off x="521208" y="1989095"/>
+            <a:ext cx="7928311" cy="3717171"/>
           </a:xfrm>
           <a:prstGeom prst="rect">
             <a:avLst/>
@@ -14655,6 +14687,40 @@
                 <a:latin typeface="Arial" panose="020B0604020202020204" pitchFamily="34" charset="0"/>
               </a:rPr>
               <a:t>felelősség</a:t>
+            </a:r>
+            <a:endParaRPr kumimoji="0" lang="hu-HU" altLang="en-US" sz="2400" b="0" i="0" u="none" strike="noStrike" cap="none" normalizeH="0" baseline="0" dirty="0">
+              <a:ln>
+                <a:noFill/>
+              </a:ln>
+              <a:solidFill>
+                <a:schemeClr val="tx1"/>
+              </a:solidFill>
+              <a:effectLst/>
+              <a:latin typeface="Arial" panose="020B0604020202020204" pitchFamily="34" charset="0"/>
+            </a:endParaRPr>
+          </a:p>
+          <a:p>
+            <a:pPr marL="0" marR="0" lvl="0" indent="0" algn="l" defTabSz="914400" rtl="0" eaLnBrk="0" fontAlgn="base" latinLnBrk="0" hangingPunct="0">
+              <a:lnSpc>
+                <a:spcPct val="150000"/>
+              </a:lnSpc>
+              <a:spcBef>
+                <a:spcPct val="0"/>
+              </a:spcBef>
+              <a:spcAft>
+                <a:spcPct val="0"/>
+              </a:spcAft>
+              <a:buClrTx/>
+              <a:buSzTx/>
+              <a:buFontTx/>
+              <a:buChar char="•"/>
+              <a:tabLst/>
+            </a:pPr>
+            <a:r>
+              <a:rPr lang="hu-HU" altLang="en-US" sz="2400" dirty="0">
+                <a:latin typeface="Arial" panose="020B0604020202020204" pitchFamily="34" charset="0"/>
+              </a:rPr>
+              <a:t> Nem helyettesít más védelmeket</a:t>
             </a:r>
             <a:endParaRPr kumimoji="0" lang="en-US" altLang="en-US" sz="2400" b="0" i="0" u="none" strike="noStrike" cap="none" normalizeH="0" baseline="0" dirty="0">
               <a:ln>
@@ -14752,13 +14818,13 @@
         </p:nvSpPr>
         <p:spPr>
           <a:xfrm>
-            <a:off x="521209" y="2146988"/>
-            <a:ext cx="6354154" cy="3489883"/>
+            <a:off x="521208" y="2146988"/>
+            <a:ext cx="6354154" cy="3732604"/>
           </a:xfrm>
         </p:spPr>
         <p:txBody>
           <a:bodyPr>
-            <a:normAutofit/>
+            <a:normAutofit fontScale="92500" lnSpcReduction="10000"/>
           </a:bodyPr>
           <a:lstStyle/>
           <a:p>
@@ -14776,8 +14842,44 @@
               <a:t>: </a:t>
             </a:r>
             <a:r>
+              <a:rPr lang="en-US" sz="2200" b="1" dirty="0"/>
+              <a:t>O</a:t>
+            </a:r>
+            <a:r>
               <a:rPr lang="en-US" sz="2200" dirty="0"/>
-              <a:t>Open Web Application Security Project</a:t>
+              <a:t>pen </a:t>
+            </a:r>
+            <a:r>
+              <a:rPr lang="en-US" sz="2200" b="1" dirty="0"/>
+              <a:t>W</a:t>
+            </a:r>
+            <a:r>
+              <a:rPr lang="en-US" sz="2200" dirty="0"/>
+              <a:t>eb </a:t>
+            </a:r>
+            <a:r>
+              <a:rPr lang="en-US" sz="2200" b="1" dirty="0"/>
+              <a:t>A</a:t>
+            </a:r>
+            <a:r>
+              <a:rPr lang="en-US" sz="2200" dirty="0"/>
+              <a:t>pplication </a:t>
+            </a:r>
+            <a:r>
+              <a:rPr lang="en-US" sz="2200" b="1" dirty="0"/>
+              <a:t>S</a:t>
+            </a:r>
+            <a:r>
+              <a:rPr lang="en-US" sz="2200" dirty="0"/>
+              <a:t>ecurity </a:t>
+            </a:r>
+            <a:r>
+              <a:rPr lang="en-US" sz="2200" b="1" dirty="0"/>
+              <a:t>P</a:t>
+            </a:r>
+            <a:r>
+              <a:rPr lang="en-US" sz="2200" dirty="0"/>
+              <a:t>roject</a:t>
             </a:r>
             <a:endParaRPr lang="hu-HU" sz="2200" dirty="0"/>
           </a:p>
@@ -14857,6 +14959,17 @@
               <a:t>nyelv</a:t>
             </a:r>
             <a:endParaRPr lang="hu-HU" sz="2200" dirty="0"/>
+          </a:p>
+          <a:p>
+            <a:pPr>
+              <a:lnSpc>
+                <a:spcPct val="150000"/>
+              </a:lnSpc>
+            </a:pPr>
+            <a:r>
+              <a:rPr lang="hu-HU" sz="2200" dirty="0"/>
+              <a:t>Nem szabvány, hanem széles körben elfogadott biztonsági tudatosságot növelő dokumentum</a:t>
+            </a:r>
           </a:p>
         </p:txBody>
       </p:sp>
@@ -14874,7 +14987,7 @@
         </p:nvSpPr>
         <p:spPr>
           <a:xfrm>
-            <a:off x="7037408" y="2727382"/>
+            <a:off x="7027360" y="2146988"/>
             <a:ext cx="4838217" cy="3277820"/>
           </a:xfrm>
           <a:prstGeom prst="rect">
@@ -14896,7 +15009,19 @@
             </a:pPr>
             <a:r>
               <a:rPr lang="en-US" b="1" dirty="0"/>
-              <a:t>OWASP Top 10 – 2025</a:t>
+              <a:t>OWASP Top 10 </a:t>
+            </a:r>
+            <a:r>
+              <a:rPr lang="hu-HU" b="1" dirty="0"/>
+              <a:t>(in </a:t>
+            </a:r>
+            <a:r>
+              <a:rPr lang="en-US" b="1" dirty="0"/>
+              <a:t>2025</a:t>
+            </a:r>
+            <a:r>
+              <a:rPr lang="hu-HU" b="1" dirty="0"/>
+              <a:t>)</a:t>
             </a:r>
             <a:endParaRPr lang="en-US" dirty="0"/>
           </a:p>
@@ -16358,8 +16483,8 @@
         </p:nvSpPr>
         <p:spPr bwMode="auto">
           <a:xfrm>
-            <a:off x="446779" y="2218882"/>
-            <a:ext cx="9654151" cy="2739211"/>
+            <a:off x="521208" y="2058948"/>
+            <a:ext cx="9654151" cy="4124206"/>
           </a:xfrm>
           <a:prstGeom prst="rect">
             <a:avLst/>
@@ -16424,9 +16549,16 @@
                 <a:latin typeface="Arial" panose="020B0604020202020204" pitchFamily="34" charset="0"/>
                 <a:cs typeface="Arial" panose="020B0604020202020204" pitchFamily="34" charset="0"/>
               </a:rPr>
-              <a:t>A támadó nem feltör – kihasznál</a:t>
-            </a:r>
-            <a:endParaRPr kumimoji="0" lang="hu-HU" altLang="en-US" sz="2800" b="0" i="0" u="none" strike="noStrike" cap="none" normalizeH="0" baseline="0" dirty="0">
+              <a:t>A támadó nem feltör – </a:t>
+            </a:r>
+            <a:r>
+              <a:rPr lang="pt-BR" sz="2800" b="1" dirty="0">
+                <a:latin typeface="Arial" panose="020B0604020202020204" pitchFamily="34" charset="0"/>
+                <a:cs typeface="Arial" panose="020B0604020202020204" pitchFamily="34" charset="0"/>
+              </a:rPr>
+              <a:t>kihasznál</a:t>
+            </a:r>
+            <a:endParaRPr kumimoji="0" lang="hu-HU" altLang="en-US" sz="2800" b="1" i="0" u="none" strike="noStrike" cap="none" normalizeH="0" baseline="0" dirty="0">
               <a:ln>
                 <a:noFill/>
               </a:ln>
@@ -16468,7 +16600,7 @@
           <a:p>
             <a:pPr marL="0" marR="0" lvl="0" indent="0" algn="l" defTabSz="914400" rtl="0" eaLnBrk="0" fontAlgn="base" latinLnBrk="0" hangingPunct="0">
               <a:lnSpc>
-                <a:spcPct val="150000"/>
+                <a:spcPct val="100000"/>
               </a:lnSpc>
               <a:spcBef>
                 <a:spcPct val="0"/>
@@ -16478,63 +16610,10 @@
               </a:spcAft>
               <a:buClrTx/>
               <a:buSzTx/>
-              <a:buFontTx/>
-              <a:buChar char="•"/>
+              <a:buNone/>
               <a:tabLst/>
             </a:pPr>
-            <a:r>
-              <a:rPr kumimoji="0" lang="hu-HU" altLang="en-US" sz="1800" b="0" i="0" u="none" strike="noStrike" cap="none" normalizeH="0" baseline="0" dirty="0">
-                <a:ln>
-                  <a:noFill/>
-                </a:ln>
-                <a:solidFill>
-                  <a:schemeClr val="tx1"/>
-                </a:solidFill>
-                <a:effectLst/>
-                <a:latin typeface="Arial" panose="020B0604020202020204" pitchFamily="34" charset="0"/>
-              </a:rPr>
-              <a:t> </a:t>
-            </a:r>
-            <a:r>
-              <a:rPr kumimoji="0" lang="en-US" altLang="en-US" sz="2400" b="0" i="0" u="none" strike="noStrike" cap="none" normalizeH="0" baseline="0" dirty="0" err="1">
-                <a:ln>
-                  <a:noFill/>
-                </a:ln>
-                <a:solidFill>
-                  <a:schemeClr val="tx1"/>
-                </a:solidFill>
-                <a:effectLst/>
-                <a:latin typeface="Arial" panose="020B0604020202020204" pitchFamily="34" charset="0"/>
-              </a:rPr>
-              <a:t>Szabványos</a:t>
-            </a:r>
-            <a:r>
-              <a:rPr kumimoji="0" lang="en-US" altLang="en-US" sz="2400" b="0" i="0" u="none" strike="noStrike" cap="none" normalizeH="0" baseline="0" dirty="0">
-                <a:ln>
-                  <a:noFill/>
-                </a:ln>
-                <a:solidFill>
-                  <a:schemeClr val="tx1"/>
-                </a:solidFill>
-                <a:effectLst/>
-                <a:latin typeface="Arial" panose="020B0604020202020204" pitchFamily="34" charset="0"/>
-              </a:rPr>
-              <a:t> HTTP </a:t>
-            </a:r>
-            <a:r>
-              <a:rPr kumimoji="0" lang="en-US" altLang="en-US" sz="2400" b="0" i="0" u="none" strike="noStrike" cap="none" normalizeH="0" baseline="0" dirty="0" err="1">
-                <a:ln>
-                  <a:noFill/>
-                </a:ln>
-                <a:solidFill>
-                  <a:schemeClr val="tx1"/>
-                </a:solidFill>
-                <a:effectLst/>
-                <a:latin typeface="Arial" panose="020B0604020202020204" pitchFamily="34" charset="0"/>
-              </a:rPr>
-              <a:t>kérések</a:t>
-            </a:r>
-            <a:endParaRPr kumimoji="0" lang="en-US" altLang="en-US" sz="2400" b="0" i="0" u="none" strike="noStrike" cap="none" normalizeH="0" baseline="0" dirty="0">
+            <a:endParaRPr kumimoji="0" lang="hu-HU" altLang="en-US" sz="1800" b="0" i="0" u="none" strike="noStrike" cap="none" normalizeH="0" baseline="0" dirty="0">
               <a:ln>
                 <a:noFill/>
               </a:ln>
@@ -16563,6 +16642,58 @@
               <a:tabLst/>
             </a:pPr>
             <a:r>
+              <a:rPr kumimoji="0" lang="hu-HU" altLang="en-US" sz="1800" b="0" i="0" u="none" strike="noStrike" cap="none" normalizeH="0" baseline="0" dirty="0">
+                <a:ln>
+                  <a:noFill/>
+                </a:ln>
+                <a:solidFill>
+                  <a:schemeClr val="tx1"/>
+                </a:solidFill>
+                <a:effectLst/>
+                <a:latin typeface="Arial" panose="020B0604020202020204" pitchFamily="34" charset="0"/>
+              </a:rPr>
+              <a:t> </a:t>
+            </a:r>
+            <a:r>
+              <a:rPr kumimoji="0" lang="en-US" altLang="en-US" sz="2400" b="0" i="0" u="none" strike="noStrike" cap="none" normalizeH="0" baseline="0" dirty="0">
+                <a:ln>
+                  <a:noFill/>
+                </a:ln>
+                <a:solidFill>
+                  <a:schemeClr val="tx1"/>
+                </a:solidFill>
+                <a:effectLst/>
+                <a:latin typeface="Arial" panose="020B0604020202020204" pitchFamily="34" charset="0"/>
+              </a:rPr>
+              <a:t>Szabványos HTTP </a:t>
+            </a:r>
+            <a:r>
+              <a:rPr kumimoji="0" lang="en-US" altLang="en-US" sz="2400" b="0" i="0" u="none" strike="noStrike" cap="none" normalizeH="0" baseline="0" dirty="0" err="1">
+                <a:ln>
+                  <a:noFill/>
+                </a:ln>
+                <a:solidFill>
+                  <a:schemeClr val="tx1"/>
+                </a:solidFill>
+                <a:effectLst/>
+                <a:latin typeface="Arial" panose="020B0604020202020204" pitchFamily="34" charset="0"/>
+              </a:rPr>
+              <a:t>kérések</a:t>
+            </a:r>
+            <a:r>
+              <a:rPr kumimoji="0" lang="hu-HU" altLang="en-US" sz="2400" b="0" i="0" u="none" strike="noStrike" cap="none" normalizeH="0" baseline="0" dirty="0" err="1">
+                <a:ln>
+                  <a:noFill/>
+                </a:ln>
+                <a:solidFill>
+                  <a:schemeClr val="tx1"/>
+                </a:solidFill>
+                <a:effectLst/>
+                <a:latin typeface="Arial" panose="020B0604020202020204" pitchFamily="34" charset="0"/>
+              </a:rPr>
+              <a:t>ből</a:t>
+            </a:r>
+            <a:r>
               <a:rPr kumimoji="0" lang="hu-HU" altLang="en-US" sz="2400" b="0" i="0" u="none" strike="noStrike" cap="none" normalizeH="0" baseline="0" dirty="0">
                 <a:ln>
                   <a:noFill/>
@@ -16573,72 +16704,7 @@
                 <a:effectLst/>
                 <a:latin typeface="Arial" panose="020B0604020202020204" pitchFamily="34" charset="0"/>
               </a:rPr>
-              <a:t> </a:t>
-            </a:r>
-            <a:r>
-              <a:rPr kumimoji="0" lang="en-US" altLang="en-US" sz="2400" b="0" i="0" u="none" strike="noStrike" cap="none" normalizeH="0" baseline="0" dirty="0" err="1">
-                <a:ln>
-                  <a:noFill/>
-                </a:ln>
-                <a:solidFill>
-                  <a:schemeClr val="tx1"/>
-                </a:solidFill>
-                <a:effectLst/>
-                <a:latin typeface="Arial" panose="020B0604020202020204" pitchFamily="34" charset="0"/>
-              </a:rPr>
-              <a:t>Böngésző</a:t>
-            </a:r>
-            <a:r>
-              <a:rPr kumimoji="0" lang="en-US" altLang="en-US" sz="2400" b="0" i="0" u="none" strike="noStrike" cap="none" normalizeH="0" baseline="0" dirty="0">
-                <a:ln>
-                  <a:noFill/>
-                </a:ln>
-                <a:solidFill>
-                  <a:schemeClr val="tx1"/>
-                </a:solidFill>
-                <a:effectLst/>
-                <a:latin typeface="Arial" panose="020B0604020202020204" pitchFamily="34" charset="0"/>
-              </a:rPr>
-              <a:t> </a:t>
-            </a:r>
-            <a:r>
-              <a:rPr kumimoji="0" lang="en-US" altLang="en-US" sz="2400" b="0" i="0" u="none" strike="noStrike" cap="none" normalizeH="0" baseline="0" dirty="0" err="1">
-                <a:ln>
-                  <a:noFill/>
-                </a:ln>
-                <a:solidFill>
-                  <a:schemeClr val="tx1"/>
-                </a:solidFill>
-                <a:effectLst/>
-                <a:latin typeface="Arial" panose="020B0604020202020204" pitchFamily="34" charset="0"/>
-              </a:rPr>
-              <a:t>normál</a:t>
-            </a:r>
-            <a:r>
-              <a:rPr kumimoji="0" lang="en-US" altLang="en-US" sz="2400" b="0" i="0" u="none" strike="noStrike" cap="none" normalizeH="0" baseline="0" dirty="0">
-                <a:ln>
-                  <a:noFill/>
-                </a:ln>
-                <a:solidFill>
-                  <a:schemeClr val="tx1"/>
-                </a:solidFill>
-                <a:effectLst/>
-                <a:latin typeface="Arial" panose="020B0604020202020204" pitchFamily="34" charset="0"/>
-              </a:rPr>
-              <a:t> </a:t>
-            </a:r>
-            <a:r>
-              <a:rPr kumimoji="0" lang="en-US" altLang="en-US" sz="2400" b="0" i="0" u="none" strike="noStrike" cap="none" normalizeH="0" baseline="0" dirty="0" err="1">
-                <a:ln>
-                  <a:noFill/>
-                </a:ln>
-                <a:solidFill>
-                  <a:schemeClr val="tx1"/>
-                </a:solidFill>
-                <a:effectLst/>
-                <a:latin typeface="Arial" panose="020B0604020202020204" pitchFamily="34" charset="0"/>
-              </a:rPr>
-              <a:t>működése</a:t>
+              <a:t> áll</a:t>
             </a:r>
             <a:endParaRPr kumimoji="0" lang="en-US" altLang="en-US" sz="2400" b="0" i="0" u="none" strike="noStrike" cap="none" normalizeH="0" baseline="0" dirty="0">
               <a:ln>
@@ -16692,6 +16758,125 @@
                 <a:effectLst/>
                 <a:latin typeface="Arial" panose="020B0604020202020204" pitchFamily="34" charset="0"/>
               </a:rPr>
+              <a:t>Böngésző</a:t>
+            </a:r>
+            <a:r>
+              <a:rPr kumimoji="0" lang="en-US" altLang="en-US" sz="2400" b="0" i="0" u="none" strike="noStrike" cap="none" normalizeH="0" baseline="0" dirty="0">
+                <a:ln>
+                  <a:noFill/>
+                </a:ln>
+                <a:solidFill>
+                  <a:schemeClr val="tx1"/>
+                </a:solidFill>
+                <a:effectLst/>
+                <a:latin typeface="Arial" panose="020B0604020202020204" pitchFamily="34" charset="0"/>
+              </a:rPr>
+              <a:t> </a:t>
+            </a:r>
+            <a:r>
+              <a:rPr kumimoji="0" lang="en-US" altLang="en-US" sz="2400" b="0" i="0" u="none" strike="noStrike" cap="none" normalizeH="0" baseline="0" dirty="0" err="1">
+                <a:ln>
+                  <a:noFill/>
+                </a:ln>
+                <a:solidFill>
+                  <a:schemeClr val="tx1"/>
+                </a:solidFill>
+                <a:effectLst/>
+                <a:latin typeface="Arial" panose="020B0604020202020204" pitchFamily="34" charset="0"/>
+              </a:rPr>
+              <a:t>normál</a:t>
+            </a:r>
+            <a:r>
+              <a:rPr kumimoji="0" lang="en-US" altLang="en-US" sz="2400" b="0" i="0" u="none" strike="noStrike" cap="none" normalizeH="0" baseline="0" dirty="0">
+                <a:ln>
+                  <a:noFill/>
+                </a:ln>
+                <a:solidFill>
+                  <a:schemeClr val="tx1"/>
+                </a:solidFill>
+                <a:effectLst/>
+                <a:latin typeface="Arial" panose="020B0604020202020204" pitchFamily="34" charset="0"/>
+              </a:rPr>
+              <a:t> </a:t>
+            </a:r>
+            <a:r>
+              <a:rPr kumimoji="0" lang="en-US" altLang="en-US" sz="2400" b="0" i="0" u="none" strike="noStrike" cap="none" normalizeH="0" baseline="0" dirty="0" err="1">
+                <a:ln>
+                  <a:noFill/>
+                </a:ln>
+                <a:solidFill>
+                  <a:schemeClr val="tx1"/>
+                </a:solidFill>
+                <a:effectLst/>
+                <a:latin typeface="Arial" panose="020B0604020202020204" pitchFamily="34" charset="0"/>
+              </a:rPr>
+              <a:t>működés</a:t>
+            </a:r>
+            <a:r>
+              <a:rPr kumimoji="0" lang="hu-HU" altLang="en-US" sz="2400" b="0" i="0" u="none" strike="noStrike" cap="none" normalizeH="0" baseline="0" dirty="0">
+                <a:ln>
+                  <a:noFill/>
+                </a:ln>
+                <a:solidFill>
+                  <a:schemeClr val="tx1"/>
+                </a:solidFill>
+                <a:effectLst/>
+                <a:latin typeface="Arial" panose="020B0604020202020204" pitchFamily="34" charset="0"/>
+              </a:rPr>
+              <a:t>ét használja ki</a:t>
+            </a:r>
+            <a:endParaRPr kumimoji="0" lang="en-US" altLang="en-US" sz="2400" b="0" i="0" u="none" strike="noStrike" cap="none" normalizeH="0" baseline="0" dirty="0">
+              <a:ln>
+                <a:noFill/>
+              </a:ln>
+              <a:solidFill>
+                <a:schemeClr val="tx1"/>
+              </a:solidFill>
+              <a:effectLst/>
+              <a:latin typeface="Arial" panose="020B0604020202020204" pitchFamily="34" charset="0"/>
+            </a:endParaRPr>
+          </a:p>
+          <a:p>
+            <a:pPr marL="0" marR="0" lvl="0" indent="0" algn="l" defTabSz="914400" rtl="0" eaLnBrk="0" fontAlgn="base" latinLnBrk="0" hangingPunct="0">
+              <a:lnSpc>
+                <a:spcPct val="150000"/>
+              </a:lnSpc>
+              <a:spcBef>
+                <a:spcPct val="0"/>
+              </a:spcBef>
+              <a:spcAft>
+                <a:spcPct val="0"/>
+              </a:spcAft>
+              <a:buClrTx/>
+              <a:buSzTx/>
+              <a:buFontTx/>
+              <a:buChar char="•"/>
+              <a:tabLst/>
+            </a:pPr>
+            <a:r>
+              <a:rPr kumimoji="0" lang="hu-HU" altLang="en-US" sz="2400" b="0" i="0" u="none" strike="noStrike" cap="none" normalizeH="0" baseline="0" dirty="0">
+                <a:ln>
+                  <a:noFill/>
+                </a:ln>
+                <a:solidFill>
+                  <a:schemeClr val="tx1"/>
+                </a:solidFill>
+                <a:effectLst/>
+                <a:latin typeface="Arial" panose="020B0604020202020204" pitchFamily="34" charset="0"/>
+              </a:rPr>
+              <a:t> </a:t>
+            </a:r>
+            <a:r>
+              <a:rPr kumimoji="0" lang="en-US" altLang="en-US" sz="2400" b="0" i="0" u="none" strike="noStrike" cap="none" normalizeH="0" baseline="0" dirty="0" err="1">
+                <a:ln>
+                  <a:noFill/>
+                </a:ln>
+                <a:solidFill>
+                  <a:schemeClr val="tx1"/>
+                </a:solidFill>
+                <a:effectLst/>
+                <a:latin typeface="Arial" panose="020B0604020202020204" pitchFamily="34" charset="0"/>
+              </a:rPr>
               <a:t>Logikai</a:t>
             </a:r>
             <a:r>
@@ -16745,6 +16930,102 @@
                 <a:latin typeface="Arial" panose="020B0604020202020204" pitchFamily="34" charset="0"/>
               </a:rPr>
               <a:t>hibák</a:t>
+            </a:r>
+            <a:r>
+              <a:rPr kumimoji="0" lang="hu-HU" altLang="en-US" sz="2400" b="0" i="0" u="none" strike="noStrike" cap="none" normalizeH="0" baseline="0" dirty="0">
+                <a:ln>
+                  <a:noFill/>
+                </a:ln>
+                <a:solidFill>
+                  <a:schemeClr val="tx1"/>
+                </a:solidFill>
+                <a:effectLst/>
+                <a:latin typeface="Arial" panose="020B0604020202020204" pitchFamily="34" charset="0"/>
+              </a:rPr>
+              <a:t> kihasználása</a:t>
+            </a:r>
+          </a:p>
+          <a:p>
+            <a:pPr marL="0" marR="0" lvl="0" indent="0" algn="l" defTabSz="914400" rtl="0" eaLnBrk="0" fontAlgn="base" latinLnBrk="0" hangingPunct="0">
+              <a:lnSpc>
+                <a:spcPct val="150000"/>
+              </a:lnSpc>
+              <a:spcBef>
+                <a:spcPct val="0"/>
+              </a:spcBef>
+              <a:spcAft>
+                <a:spcPct val="0"/>
+              </a:spcAft>
+              <a:buClrTx/>
+              <a:buSzTx/>
+              <a:buFontTx/>
+              <a:buChar char="•"/>
+              <a:tabLst/>
+            </a:pPr>
+            <a:endParaRPr lang="hu-HU" altLang="en-US" sz="2400" dirty="0">
+              <a:latin typeface="Arial" panose="020B0604020202020204" pitchFamily="34" charset="0"/>
+            </a:endParaRPr>
+          </a:p>
+          <a:p>
+            <a:pPr marL="0" lvl="0" indent="0" eaLnBrk="0" fontAlgn="base" hangingPunct="0">
+              <a:lnSpc>
+                <a:spcPct val="150000"/>
+              </a:lnSpc>
+              <a:spcBef>
+                <a:spcPct val="0"/>
+              </a:spcBef>
+              <a:spcAft>
+                <a:spcPct val="0"/>
+              </a:spcAft>
+              <a:buNone/>
+            </a:pPr>
+            <a:r>
+              <a:rPr lang="hu-HU" sz="2400" dirty="0"/>
+              <a:t>A</a:t>
+            </a:r>
+            <a:r>
+              <a:rPr lang="en-US" sz="2400" dirty="0"/>
+              <a:t> </a:t>
+            </a:r>
+            <a:r>
+              <a:rPr lang="en-US" sz="2400" dirty="0" err="1"/>
+              <a:t>webbiztonság</a:t>
+            </a:r>
+            <a:r>
+              <a:rPr lang="en-US" sz="2400" dirty="0"/>
+              <a:t> </a:t>
+            </a:r>
+            <a:r>
+              <a:rPr lang="en-US" sz="2400" dirty="0" err="1"/>
+              <a:t>elsősorban</a:t>
+            </a:r>
+            <a:r>
+              <a:rPr lang="en-US" sz="2400" dirty="0"/>
+              <a:t> </a:t>
+            </a:r>
+            <a:r>
+              <a:rPr lang="en-US" sz="2400" b="1" dirty="0" err="1"/>
+              <a:t>logikai</a:t>
+            </a:r>
+            <a:r>
+              <a:rPr lang="en-US" sz="2400" b="1" dirty="0"/>
+              <a:t> </a:t>
+            </a:r>
+            <a:r>
+              <a:rPr lang="en-US" sz="2400" b="1" dirty="0" err="1"/>
+              <a:t>tervezési</a:t>
+            </a:r>
+            <a:r>
+              <a:rPr lang="en-US" sz="2400" b="1" dirty="0"/>
+              <a:t> </a:t>
+            </a:r>
+            <a:r>
+              <a:rPr lang="en-US" sz="2400" b="1" dirty="0" err="1"/>
+              <a:t>kérdés</a:t>
+            </a:r>
+            <a:r>
+              <a:rPr lang="hu-HU" sz="2400" b="1" dirty="0"/>
+              <a:t>.</a:t>
             </a:r>
             <a:endParaRPr lang="hu-HU" altLang="en-US" sz="2400" dirty="0">
               <a:latin typeface="Arial" panose="020B0604020202020204" pitchFamily="34" charset="0"/>

</xml_diff>